<commit_message>
implement new feature for enhanced user experience
</commit_message>
<xml_diff>
--- a/ECE_157B_272B_Homework2_Template.pptx
+++ b/ECE_157B_272B_Homework2_Template.pptx
@@ -2429,7 +2429,7 @@
         <p:spPr>
           <a:xfrm>
             <a:off x="623455" y="1413164"/>
-            <a:ext cx="11239994" cy="6145272"/>
+            <a:ext cx="11239994" cy="6160661"/>
           </a:xfrm>
           <a:prstGeom prst="rect">
             <a:avLst/>
@@ -2492,13 +2492,13 @@
               </a:lnSpc>
             </a:pPr>
             <a:r>
-              <a:rPr lang="en-US" dirty="0">
+              <a:rPr lang="en-US" sz="1200" dirty="0">
                 <a:latin typeface="Consolas" panose="020B0609020204030204" pitchFamily="49" charset="0"/>
               </a:rPr>
               <a:t>Context: </a:t>
             </a:r>
             <a:r>
-              <a:rPr lang="en-US" b="0" dirty="0">
+              <a:rPr lang="en-US" sz="1200" b="0" dirty="0">
                 <a:solidFill>
                   <a:srgbClr val="CE9178"/>
                 </a:solidFill>
@@ -2508,7 +2508,7 @@
               <a:t>The model will output logits for the start and end positions of the answer in the input IDs, as </a:t>
             </a:r>
             <a:r>
-              <a:rPr lang="en-US" b="0" dirty="0" err="1">
+              <a:rPr lang="en-US" sz="1200" b="0" dirty="0" err="1">
                 <a:solidFill>
                   <a:srgbClr val="CE9178"/>
                 </a:solidFill>
@@ -2518,7 +2518,7 @@
               <a:t>wesaw</a:t>
             </a:r>
             <a:r>
-              <a:rPr lang="en-US" b="0" dirty="0">
+              <a:rPr lang="en-US" sz="1200" b="0" dirty="0">
                 <a:solidFill>
                   <a:srgbClr val="CE9178"/>
                 </a:solidFill>
@@ -2528,7 +2528,7 @@
               <a:t> during our exploration of the question-answering pipeline. The post-processing step will </a:t>
             </a:r>
             <a:r>
-              <a:rPr lang="en-US" b="0" dirty="0" err="1">
+              <a:rPr lang="en-US" sz="1200" b="0" dirty="0" err="1">
                 <a:solidFill>
                   <a:srgbClr val="CE9178"/>
                 </a:solidFill>
@@ -2538,7 +2538,7 @@
               <a:t>besimilar</a:t>
             </a:r>
             <a:r>
-              <a:rPr lang="en-US" b="0" dirty="0">
+              <a:rPr lang="en-US" sz="1200" b="0" dirty="0">
                 <a:solidFill>
                   <a:srgbClr val="CE9178"/>
                 </a:solidFill>
@@ -2548,7 +2548,7 @@
               <a:t> to what we did there, so </a:t>
             </a:r>
             <a:r>
-              <a:rPr lang="en-US" b="0" dirty="0" err="1">
+              <a:rPr lang="en-US" sz="1200" b="0" dirty="0" err="1">
                 <a:solidFill>
                   <a:srgbClr val="CE9178"/>
                 </a:solidFill>
@@ -2558,7 +2558,7 @@
               <a:t>hereʼs</a:t>
             </a:r>
             <a:r>
-              <a:rPr lang="en-US" b="0" dirty="0">
+              <a:rPr lang="en-US" sz="1200" b="0" dirty="0">
                 <a:solidFill>
                   <a:srgbClr val="CE9178"/>
                 </a:solidFill>
@@ -2568,7 +2568,7 @@
               <a:t> a quick reminder of the actions we </a:t>
             </a:r>
             <a:r>
-              <a:rPr lang="en-US" b="0" dirty="0" err="1">
+              <a:rPr lang="en-US" sz="1200" b="0" dirty="0" err="1">
                 <a:solidFill>
                   <a:srgbClr val="CE9178"/>
                 </a:solidFill>
@@ -2578,7 +2578,7 @@
               <a:t>took:We</a:t>
             </a:r>
             <a:r>
-              <a:rPr lang="en-US" b="0" dirty="0">
+              <a:rPr lang="en-US" sz="1200" b="0" dirty="0">
                 <a:solidFill>
                   <a:srgbClr val="CE9178"/>
                 </a:solidFill>
@@ -2588,7 +2588,7 @@
               <a:t> masked the start and end logits corresponding to tokens outside of the </a:t>
             </a:r>
             <a:r>
-              <a:rPr lang="en-US" b="0" dirty="0" err="1">
+              <a:rPr lang="en-US" sz="1200" b="0" dirty="0" err="1">
                 <a:solidFill>
                   <a:srgbClr val="CE9178"/>
                 </a:solidFill>
@@ -2598,7 +2598,7 @@
               <a:t>context.We</a:t>
             </a:r>
             <a:r>
-              <a:rPr lang="en-US" b="0" dirty="0">
+              <a:rPr lang="en-US" sz="1200" b="0" dirty="0">
                 <a:solidFill>
                   <a:srgbClr val="CE9178"/>
                 </a:solidFill>
@@ -2608,7 +2608,7 @@
               <a:t> then converted the start and end logits into probabilities using a </a:t>
             </a:r>
             <a:r>
-              <a:rPr lang="en-US" b="0" dirty="0" err="1">
+              <a:rPr lang="en-US" sz="1200" b="0" dirty="0" err="1">
                 <a:solidFill>
                   <a:srgbClr val="CE9178"/>
                 </a:solidFill>
@@ -2618,7 +2618,7 @@
               <a:t>somax.We</a:t>
             </a:r>
             <a:r>
-              <a:rPr lang="en-US" b="0" dirty="0">
+              <a:rPr lang="en-US" sz="1200" b="0" dirty="0">
                 <a:solidFill>
                   <a:srgbClr val="CE9178"/>
                 </a:solidFill>
@@ -2628,7 +2628,7 @@
               <a:t> attributed a score to each (</a:t>
             </a:r>
             <a:r>
-              <a:rPr lang="en-US" b="0" dirty="0" err="1">
+              <a:rPr lang="en-US" sz="1200" b="0" dirty="0" err="1">
                 <a:solidFill>
                   <a:srgbClr val="CE9178"/>
                 </a:solidFill>
@@ -2638,7 +2638,7 @@
               <a:t>start_token</a:t>
             </a:r>
             <a:r>
-              <a:rPr lang="en-US" b="0" dirty="0">
+              <a:rPr lang="en-US" sz="1200" b="0" dirty="0">
                 <a:solidFill>
                   <a:srgbClr val="CE9178"/>
                 </a:solidFill>
@@ -2648,7 +2648,7 @@
               <a:t>, </a:t>
             </a:r>
             <a:r>
-              <a:rPr lang="en-US" b="0" dirty="0" err="1">
+              <a:rPr lang="en-US" sz="1200" b="0" dirty="0" err="1">
                 <a:solidFill>
                   <a:srgbClr val="CE9178"/>
                 </a:solidFill>
@@ -2658,7 +2658,7 @@
               <a:t>end_token</a:t>
             </a:r>
             <a:r>
-              <a:rPr lang="en-US" b="0" dirty="0">
+              <a:rPr lang="en-US" sz="1200" b="0" dirty="0">
                 <a:solidFill>
                   <a:srgbClr val="CE9178"/>
                 </a:solidFill>
@@ -2668,7 +2668,7 @@
               <a:t>) pair by taking the product of </a:t>
             </a:r>
             <a:r>
-              <a:rPr lang="en-US" b="0" dirty="0" err="1">
+              <a:rPr lang="en-US" sz="1200" b="0" dirty="0" err="1">
                 <a:solidFill>
                   <a:srgbClr val="CE9178"/>
                 </a:solidFill>
@@ -2678,7 +2678,7 @@
               <a:t>thecorresponding</a:t>
             </a:r>
             <a:r>
-              <a:rPr lang="en-US" b="0" dirty="0">
+              <a:rPr lang="en-US" sz="1200" b="0" dirty="0">
                 <a:solidFill>
                   <a:srgbClr val="CE9178"/>
                 </a:solidFill>
@@ -2688,7 +2688,7 @@
               <a:t> two </a:t>
             </a:r>
             <a:r>
-              <a:rPr lang="en-US" b="0" dirty="0" err="1">
+              <a:rPr lang="en-US" sz="1200" b="0" dirty="0" err="1">
                 <a:solidFill>
                   <a:srgbClr val="CE9178"/>
                 </a:solidFill>
@@ -2698,7 +2698,7 @@
               <a:t>probabilities.We</a:t>
             </a:r>
             <a:r>
-              <a:rPr lang="en-US" b="0" dirty="0">
+              <a:rPr lang="en-US" sz="1200" b="0" dirty="0">
                 <a:solidFill>
                   <a:srgbClr val="CE9178"/>
                 </a:solidFill>
@@ -2707,7 +2707,7 @@
               </a:rPr>
               <a:t> looked for the pair with the maximum score that yielded a valid answer (e.g., a</a:t>
             </a:r>
-            <a:endParaRPr lang="en-US" b="0" dirty="0">
+            <a:endParaRPr lang="en-US" sz="1200" b="0" dirty="0">
               <a:solidFill>
                 <a:srgbClr val="D4D4D4"/>
               </a:solidFill>
@@ -2722,7 +2722,7 @@
               </a:lnSpc>
             </a:pPr>
             <a:r>
-              <a:rPr lang="en-US" b="0" dirty="0" err="1">
+              <a:rPr lang="en-US" sz="1200" b="0" dirty="0" err="1">
                 <a:solidFill>
                   <a:srgbClr val="CE9178"/>
                 </a:solidFill>
@@ -2732,7 +2732,7 @@
               <a:t>start_token</a:t>
             </a:r>
             <a:r>
-              <a:rPr lang="en-US" b="0" dirty="0">
+              <a:rPr lang="en-US" sz="1200" b="0" dirty="0">
                 <a:solidFill>
                   <a:srgbClr val="CE9178"/>
                 </a:solidFill>
@@ -2742,7 +2742,7 @@
               <a:t> lower than </a:t>
             </a:r>
             <a:r>
-              <a:rPr lang="en-US" b="0" dirty="0" err="1">
+              <a:rPr lang="en-US" sz="1200" b="0" dirty="0" err="1">
                 <a:solidFill>
                   <a:srgbClr val="CE9178"/>
                 </a:solidFill>
@@ -2752,7 +2752,7 @@
               <a:t>end_token</a:t>
             </a:r>
             <a:r>
-              <a:rPr lang="en-US" b="0" dirty="0">
+              <a:rPr lang="en-US" sz="1200" b="0" dirty="0">
                 <a:solidFill>
                   <a:srgbClr val="CE9178"/>
                 </a:solidFill>
@@ -2761,7 +2761,7 @@
               </a:rPr>
               <a:t>)</a:t>
             </a:r>
-            <a:endParaRPr lang="en-US" b="0" dirty="0">
+            <a:endParaRPr lang="en-US" sz="1200" b="0" dirty="0">
               <a:solidFill>
                 <a:srgbClr val="CE9178"/>
               </a:solidFill>
@@ -2866,7 +2866,7 @@
               <a:rPr lang="en-US" dirty="0">
                 <a:latin typeface="Consolas" panose="020B0609020204030204" pitchFamily="49" charset="0"/>
               </a:rPr>
-              <a:t>Comment on Both Model’s Answer:</a:t>
+              <a:t>Comment on Both Model’s Answer: Here the model fails completely, the response is vague and useless. The RAG gives a decent response that summarizes the pdf, with a useful bullet-point format. </a:t>
             </a:r>
           </a:p>
           <a:p>
@@ -2929,8 +2929,38 @@
         </p:blipFill>
         <p:spPr>
           <a:xfrm>
-            <a:off x="3855027" y="4159827"/>
+            <a:off x="3814686" y="3246848"/>
             <a:ext cx="5105400" cy="990600"/>
+          </a:xfrm>
+          <a:prstGeom prst="rect">
+            <a:avLst/>
+          </a:prstGeom>
+        </p:spPr>
+      </p:pic>
+      <p:pic>
+        <p:nvPicPr>
+          <p:cNvPr id="4" name="Picture 3">
+            <a:extLst>
+              <a:ext uri="{FF2B5EF4-FFF2-40B4-BE49-F238E27FC236}">
+                <a16:creationId xmlns:a16="http://schemas.microsoft.com/office/drawing/2014/main" id="{A0169340-8108-D990-24C1-73A19111896C}"/>
+              </a:ext>
+            </a:extLst>
+          </p:cNvPr>
+          <p:cNvPicPr>
+            <a:picLocks noChangeAspect="1"/>
+          </p:cNvPicPr>
+          <p:nvPr/>
+        </p:nvPicPr>
+        <p:blipFill>
+          <a:blip r:embed="rId3"/>
+          <a:stretch>
+            <a:fillRect/>
+          </a:stretch>
+        </p:blipFill>
+        <p:spPr>
+          <a:xfrm>
+            <a:off x="3581400" y="4399962"/>
+            <a:ext cx="7772400" cy="1044874"/>
           </a:xfrm>
           <a:prstGeom prst="rect">
             <a:avLst/>
@@ -3030,7 +3060,7 @@
         <p:spPr>
           <a:xfrm>
             <a:off x="623455" y="1413164"/>
-            <a:ext cx="11239994" cy="5355312"/>
+            <a:ext cx="11239994" cy="5539978"/>
           </a:xfrm>
           <a:prstGeom prst="rect">
             <a:avLst/>
@@ -3240,7 +3270,7 @@
               <a:rPr lang="en-US" dirty="0">
                 <a:latin typeface="Consolas" panose="020B0609020204030204" pitchFamily="49" charset="0"/>
               </a:rPr>
-              <a:t>RAG Output Screenshot:</a:t>
+              <a:t>RAG Output Screenshot: </a:t>
             </a:r>
             <a:endParaRPr lang="en-US" sz="1600" dirty="0">
               <a:latin typeface="Segoe UI" panose="020B0502040204020203" pitchFamily="34" charset="0"/>
@@ -3280,28 +3310,8 @@
               <a:rPr lang="en-US" dirty="0">
                 <a:latin typeface="Consolas" panose="020B0609020204030204" pitchFamily="49" charset="0"/>
               </a:rPr>
-              <a:t>Comment on Both Model’s Answer:</a:t>
-            </a:r>
-          </a:p>
-          <a:p>
-            <a:pPr lvl="0">
-              <a:spcAft>
-                <a:spcPts val="600"/>
-              </a:spcAft>
-              <a:defRPr/>
-            </a:pPr>
-            <a:endParaRPr lang="en-US" sz="1600" dirty="0">
-              <a:latin typeface="Segoe UI" panose="020B0502040204020203" pitchFamily="34" charset="0"/>
-              <a:cs typeface="Segoe UI" panose="020B0502040204020203" pitchFamily="34" charset="0"/>
-            </a:endParaRPr>
-          </a:p>
-          <a:p>
-            <a:pPr lvl="0">
-              <a:spcAft>
-                <a:spcPts val="600"/>
-              </a:spcAft>
-              <a:defRPr/>
-            </a:pPr>
+              <a:t>Comment on Both Model’s Answer: Here the RAG model fails as once again the abundance of context serves as a distraction. The RAG model says a lot that seems right but is definitely wrong, knowing the real answer. However, the model we trained is spot on and very concise, but this might be because of the very clear answer that is in the context. </a:t>
+            </a:r>
             <a:endParaRPr lang="en-US" sz="1600" dirty="0">
               <a:latin typeface="Segoe UI" panose="020B0502040204020203" pitchFamily="34" charset="0"/>
               <a:cs typeface="Segoe UI" panose="020B0502040204020203" pitchFamily="34" charset="0"/>
@@ -3343,8 +3353,38 @@
         </p:blipFill>
         <p:spPr>
           <a:xfrm>
-            <a:off x="3832514" y="3429000"/>
+            <a:off x="3832514" y="3307976"/>
             <a:ext cx="3695700" cy="990600"/>
+          </a:xfrm>
+          <a:prstGeom prst="rect">
+            <a:avLst/>
+          </a:prstGeom>
+        </p:spPr>
+      </p:pic>
+      <p:pic>
+        <p:nvPicPr>
+          <p:cNvPr id="4" name="Picture 3">
+            <a:extLst>
+              <a:ext uri="{FF2B5EF4-FFF2-40B4-BE49-F238E27FC236}">
+                <a16:creationId xmlns:a16="http://schemas.microsoft.com/office/drawing/2014/main" id="{37A72142-8FA9-A206-4430-9016840606C7}"/>
+              </a:ext>
+            </a:extLst>
+          </p:cNvPr>
+          <p:cNvPicPr>
+            <a:picLocks noChangeAspect="1"/>
+          </p:cNvPicPr>
+          <p:nvPr/>
+        </p:nvPicPr>
+        <p:blipFill>
+          <a:blip r:embed="rId3"/>
+          <a:stretch>
+            <a:fillRect/>
+          </a:stretch>
+        </p:blipFill>
+        <p:spPr>
+          <a:xfrm>
+            <a:off x="3487767" y="4298576"/>
+            <a:ext cx="9213320" cy="990599"/>
           </a:xfrm>
           <a:prstGeom prst="rect">
             <a:avLst/>
@@ -3412,10 +3452,29 @@
           </a:xfrm>
         </p:spPr>
         <p:txBody>
-          <a:bodyPr/>
+          <a:bodyPr>
+            <a:normAutofit/>
+          </a:bodyPr>
           <a:lstStyle/>
           <a:p>
-            <a:endParaRPr lang="en-US" dirty="0"/>
+            <a:r>
+              <a:rPr lang="en-US" sz="1400" dirty="0"/>
+              <a:t>Generally speaking, BERT performs the best in situations where the answer to the problem is in the limited context that we gave it. Situations like the login instructions for Hugging Face, where the question can be encapsulated by a single answer like “log into </a:t>
+            </a:r>
+            <a:r>
+              <a:rPr lang="en-US" sz="1400" dirty="0" err="1"/>
+              <a:t>HuggingFace</a:t>
+            </a:r>
+            <a:r>
+              <a:rPr lang="en-US" sz="1400" dirty="0"/>
+              <a:t>.” However in most of the cases, the extra context afforded by processing the entire PDF allows the RAG model to generate much better responses in general with greater technical detail. It can even pull together information from different parts of the PDF, as opposed to BERT which can only pull information from the paragraph given. </a:t>
+            </a:r>
+          </a:p>
+          <a:p>
+            <a:r>
+              <a:rPr lang="en-US" sz="1400" dirty="0"/>
+              <a:t>However, it’s worth noting that the playing field isn’t exactly equal here – the BERT model relies on the user copying over the paragraph that contains the information. In essence, a lot of the work is already done by the user instead of the model. The RAG model is forced to look through the entire context to determine what’s important.  It’s also worth nothing that the RAG model didn’t result in uniformly better results as sometimes the extra context appeared to distract the model from the real answer whereas BERT would do a better job zooming into the answer. </a:t>
+            </a:r>
           </a:p>
         </p:txBody>
       </p:sp>
@@ -3503,7 +3562,7 @@
         <p:spPr>
           <a:xfrm>
             <a:off x="623455" y="1413164"/>
-            <a:ext cx="2008534" cy="5016758"/>
+            <a:ext cx="2008534" cy="5509200"/>
           </a:xfrm>
           <a:prstGeom prst="rect">
             <a:avLst/>
@@ -3537,17 +3596,266 @@
               </a:spcAft>
               <a:defRPr/>
             </a:pPr>
-            <a:r>
-              <a:rPr lang="en-US" dirty="0">
-                <a:latin typeface="Segoe UI" panose="020B0502040204020203" pitchFamily="34" charset="0"/>
-                <a:cs typeface="Segoe UI" panose="020B0502040204020203" pitchFamily="34" charset="0"/>
-              </a:rPr>
-              <a:t>	</a:t>
-            </a:r>
-            <a:endParaRPr lang="en-US" dirty="0">
+            <a:endParaRPr lang="en-US" sz="1200" dirty="0">
+              <a:latin typeface="Segoe UI" panose="020B0502040204020203" pitchFamily="34" charset="0"/>
+              <a:cs typeface="Segoe UI" panose="020B0502040204020203" pitchFamily="34" charset="0"/>
+            </a:endParaRPr>
+          </a:p>
+          <a:p>
+            <a:pPr>
+              <a:lnSpc>
+                <a:spcPts val="1350"/>
+              </a:lnSpc>
+            </a:pPr>
+            <a:r>
+              <a:rPr lang="en-US" sz="1200" b="0" dirty="0" err="1">
+                <a:solidFill>
+                  <a:srgbClr val="9CDCFE"/>
+                </a:solidFill>
+                <a:effectLst/>
+                <a:latin typeface="Menlo" panose="020B0609030804020204" pitchFamily="49" charset="0"/>
+              </a:rPr>
+              <a:t>model_type</a:t>
+            </a:r>
+            <a:r>
+              <a:rPr lang="en-US" sz="1200" b="0" dirty="0">
+                <a:solidFill>
+                  <a:srgbClr val="D4D4D4"/>
+                </a:solidFill>
+                <a:effectLst/>
+                <a:latin typeface="Menlo" panose="020B0609030804020204" pitchFamily="49" charset="0"/>
+              </a:rPr>
+              <a:t> = </a:t>
+            </a:r>
+            <a:r>
+              <a:rPr lang="en-US" sz="1200" b="0" dirty="0">
+                <a:solidFill>
+                  <a:srgbClr val="CE9178"/>
+                </a:solidFill>
+                <a:effectLst/>
+                <a:latin typeface="Menlo" panose="020B0609030804020204" pitchFamily="49" charset="0"/>
+              </a:rPr>
+              <a:t>'</a:t>
+            </a:r>
+            <a:r>
+              <a:rPr lang="en-US" sz="1200" b="0" dirty="0" err="1">
+                <a:solidFill>
+                  <a:srgbClr val="CE9178"/>
+                </a:solidFill>
+                <a:effectLst/>
+                <a:latin typeface="Menlo" panose="020B0609030804020204" pitchFamily="49" charset="0"/>
+              </a:rPr>
+              <a:t>bert</a:t>
+            </a:r>
+            <a:r>
+              <a:rPr lang="en-US" sz="1200" b="0" dirty="0">
+                <a:solidFill>
+                  <a:srgbClr val="CE9178"/>
+                </a:solidFill>
+                <a:effectLst/>
+                <a:latin typeface="Menlo" panose="020B0609030804020204" pitchFamily="49" charset="0"/>
+              </a:rPr>
+              <a:t>'</a:t>
+            </a:r>
+            <a:endParaRPr lang="en-US" sz="1200" b="0" dirty="0">
               <a:solidFill>
-                <a:schemeClr val="accent1"/>
+                <a:srgbClr val="D4D4D4"/>
               </a:solidFill>
+              <a:effectLst/>
+              <a:latin typeface="Menlo" panose="020B0609030804020204" pitchFamily="49" charset="0"/>
+            </a:endParaRPr>
+          </a:p>
+          <a:p>
+            <a:pPr>
+              <a:lnSpc>
+                <a:spcPts val="1350"/>
+              </a:lnSpc>
+            </a:pPr>
+            <a:r>
+              <a:rPr lang="en-US" sz="1200" b="0" dirty="0" err="1">
+                <a:solidFill>
+                  <a:srgbClr val="9CDCFE"/>
+                </a:solidFill>
+                <a:effectLst/>
+                <a:latin typeface="Menlo" panose="020B0609030804020204" pitchFamily="49" charset="0"/>
+              </a:rPr>
+              <a:t>model_version</a:t>
+            </a:r>
+            <a:r>
+              <a:rPr lang="en-US" sz="1200" b="0" dirty="0">
+                <a:solidFill>
+                  <a:srgbClr val="D4D4D4"/>
+                </a:solidFill>
+                <a:effectLst/>
+                <a:latin typeface="Menlo" panose="020B0609030804020204" pitchFamily="49" charset="0"/>
+              </a:rPr>
+              <a:t> = </a:t>
+            </a:r>
+            <a:r>
+              <a:rPr lang="en-US" sz="1200" b="0" dirty="0">
+                <a:solidFill>
+                  <a:srgbClr val="CE9178"/>
+                </a:solidFill>
+                <a:effectLst/>
+                <a:latin typeface="Menlo" panose="020B0609030804020204" pitchFamily="49" charset="0"/>
+              </a:rPr>
+              <a:t>'</a:t>
+            </a:r>
+            <a:r>
+              <a:rPr lang="en-US" sz="1200" b="0" dirty="0" err="1">
+                <a:solidFill>
+                  <a:srgbClr val="CE9178"/>
+                </a:solidFill>
+                <a:effectLst/>
+                <a:latin typeface="Menlo" panose="020B0609030804020204" pitchFamily="49" charset="0"/>
+              </a:rPr>
+              <a:t>bert</a:t>
+            </a:r>
+            <a:r>
+              <a:rPr lang="en-US" sz="1200" b="0" dirty="0">
+                <a:solidFill>
+                  <a:srgbClr val="CE9178"/>
+                </a:solidFill>
+                <a:effectLst/>
+                <a:latin typeface="Menlo" panose="020B0609030804020204" pitchFamily="49" charset="0"/>
+              </a:rPr>
+              <a:t>-base-uncased'</a:t>
+            </a:r>
+            <a:endParaRPr lang="en-US" sz="1200" b="0" dirty="0">
+              <a:solidFill>
+                <a:srgbClr val="D4D4D4"/>
+              </a:solidFill>
+              <a:effectLst/>
+              <a:latin typeface="Menlo" panose="020B0609030804020204" pitchFamily="49" charset="0"/>
+            </a:endParaRPr>
+          </a:p>
+          <a:p>
+            <a:pPr>
+              <a:spcAft>
+                <a:spcPts val="600"/>
+              </a:spcAft>
+              <a:defRPr/>
+            </a:pPr>
+            <a:r>
+              <a:rPr lang="en-US" sz="1200" b="0" dirty="0">
+                <a:solidFill>
+                  <a:srgbClr val="9CDCFE"/>
+                </a:solidFill>
+                <a:effectLst/>
+                <a:latin typeface="Menlo" panose="020B0609030804020204" pitchFamily="49" charset="0"/>
+              </a:rPr>
+              <a:t>model</a:t>
+            </a:r>
+            <a:r>
+              <a:rPr lang="en-US" sz="1200" b="0" dirty="0">
+                <a:solidFill>
+                  <a:srgbClr val="D4D4D4"/>
+                </a:solidFill>
+                <a:effectLst/>
+                <a:latin typeface="Menlo" panose="020B0609030804020204" pitchFamily="49" charset="0"/>
+              </a:rPr>
+              <a:t> = </a:t>
+            </a:r>
+            <a:r>
+              <a:rPr lang="en-US" sz="1200" b="0" dirty="0" err="1">
+                <a:solidFill>
+                  <a:srgbClr val="4EC9B0"/>
+                </a:solidFill>
+                <a:effectLst/>
+                <a:latin typeface="Menlo" panose="020B0609030804020204" pitchFamily="49" charset="0"/>
+              </a:rPr>
+              <a:t>BertModel</a:t>
+            </a:r>
+            <a:r>
+              <a:rPr lang="en-US" sz="1200" b="0" dirty="0" err="1">
+                <a:solidFill>
+                  <a:srgbClr val="D4D4D4"/>
+                </a:solidFill>
+                <a:effectLst/>
+                <a:latin typeface="Menlo" panose="020B0609030804020204" pitchFamily="49" charset="0"/>
+              </a:rPr>
+              <a:t>.</a:t>
+            </a:r>
+            <a:r>
+              <a:rPr lang="en-US" sz="1200" b="0" dirty="0" err="1">
+                <a:solidFill>
+                  <a:srgbClr val="DCDCAA"/>
+                </a:solidFill>
+                <a:effectLst/>
+                <a:latin typeface="Menlo" panose="020B0609030804020204" pitchFamily="49" charset="0"/>
+              </a:rPr>
+              <a:t>from_pretrained</a:t>
+            </a:r>
+            <a:r>
+              <a:rPr lang="en-US" sz="1200" b="0" dirty="0">
+                <a:solidFill>
+                  <a:srgbClr val="D4D4D4"/>
+                </a:solidFill>
+                <a:effectLst/>
+                <a:latin typeface="Menlo" panose="020B0609030804020204" pitchFamily="49" charset="0"/>
+              </a:rPr>
+              <a:t>(</a:t>
+            </a:r>
+            <a:r>
+              <a:rPr lang="en-US" sz="1200" b="0" dirty="0" err="1">
+                <a:solidFill>
+                  <a:srgbClr val="9CDCFE"/>
+                </a:solidFill>
+                <a:effectLst/>
+                <a:latin typeface="Menlo" panose="020B0609030804020204" pitchFamily="49" charset="0"/>
+              </a:rPr>
+              <a:t>model_version</a:t>
+            </a:r>
+            <a:r>
+              <a:rPr lang="en-US" sz="1200" b="0" dirty="0">
+                <a:solidFill>
+                  <a:srgbClr val="D4D4D4"/>
+                </a:solidFill>
+                <a:effectLst/>
+                <a:latin typeface="Menlo" panose="020B0609030804020204" pitchFamily="49" charset="0"/>
+              </a:rPr>
+              <a:t>, </a:t>
+            </a:r>
+            <a:r>
+              <a:rPr lang="en-US" sz="1200" b="0" dirty="0" err="1">
+                <a:solidFill>
+                  <a:srgbClr val="9CDCFE"/>
+                </a:solidFill>
+                <a:effectLst/>
+                <a:latin typeface="Menlo" panose="020B0609030804020204" pitchFamily="49" charset="0"/>
+              </a:rPr>
+              <a:t>output_attentions</a:t>
+            </a:r>
+            <a:r>
+              <a:rPr lang="en-US" sz="1200" b="0" dirty="0">
+                <a:solidFill>
+                  <a:srgbClr val="D4D4D4"/>
+                </a:solidFill>
+                <a:effectLst/>
+                <a:latin typeface="Menlo" panose="020B0609030804020204" pitchFamily="49" charset="0"/>
+              </a:rPr>
+              <a:t>=</a:t>
+            </a:r>
+            <a:r>
+              <a:rPr lang="en-US" sz="1200" b="0" dirty="0">
+                <a:solidFill>
+                  <a:srgbClr val="569CD6"/>
+                </a:solidFill>
+                <a:effectLst/>
+                <a:latin typeface="Menlo" panose="020B0609030804020204" pitchFamily="49" charset="0"/>
+              </a:rPr>
+              <a:t>True</a:t>
+            </a:r>
+            <a:r>
+              <a:rPr lang="en-US" sz="1200" dirty="0">
+                <a:solidFill>
+                  <a:srgbClr val="D4D4D4"/>
+                </a:solidFill>
+                <a:latin typeface="Menlo" panose="020B0609030804020204" pitchFamily="49" charset="0"/>
+              </a:rPr>
+              <a:t>)</a:t>
+            </a:r>
+            <a:endParaRPr lang="en-US" sz="1200" dirty="0">
               <a:latin typeface="Segoe UI" panose="020B0502040204020203" pitchFamily="34" charset="0"/>
               <a:cs typeface="Segoe UI" panose="020B0502040204020203" pitchFamily="34" charset="0"/>
             </a:endParaRPr>
@@ -3583,54 +3891,6 @@
               </a:spcAft>
               <a:defRPr/>
             </a:pPr>
-            <a:endParaRPr lang="en-US" dirty="0">
-              <a:latin typeface="Segoe UI" panose="020B0502040204020203" pitchFamily="34" charset="0"/>
-              <a:cs typeface="Segoe UI" panose="020B0502040204020203" pitchFamily="34" charset="0"/>
-            </a:endParaRPr>
-          </a:p>
-          <a:p>
-            <a:pPr lvl="0">
-              <a:spcAft>
-                <a:spcPts val="600"/>
-              </a:spcAft>
-              <a:defRPr/>
-            </a:pPr>
-            <a:endParaRPr lang="en-US" dirty="0">
-              <a:latin typeface="Segoe UI" panose="020B0502040204020203" pitchFamily="34" charset="0"/>
-              <a:cs typeface="Segoe UI" panose="020B0502040204020203" pitchFamily="34" charset="0"/>
-            </a:endParaRPr>
-          </a:p>
-          <a:p>
-            <a:pPr lvl="0">
-              <a:spcAft>
-                <a:spcPts val="600"/>
-              </a:spcAft>
-              <a:defRPr/>
-            </a:pPr>
-            <a:endParaRPr lang="en-US" dirty="0">
-              <a:latin typeface="Segoe UI" panose="020B0502040204020203" pitchFamily="34" charset="0"/>
-              <a:cs typeface="Segoe UI" panose="020B0502040204020203" pitchFamily="34" charset="0"/>
-            </a:endParaRPr>
-          </a:p>
-          <a:p>
-            <a:pPr lvl="0">
-              <a:spcAft>
-                <a:spcPts val="600"/>
-              </a:spcAft>
-              <a:defRPr/>
-            </a:pPr>
-            <a:endParaRPr lang="en-US" dirty="0">
-              <a:latin typeface="Segoe UI" panose="020B0502040204020203" pitchFamily="34" charset="0"/>
-              <a:cs typeface="Segoe UI" panose="020B0502040204020203" pitchFamily="34" charset="0"/>
-            </a:endParaRPr>
-          </a:p>
-          <a:p>
-            <a:pPr lvl="0">
-              <a:spcAft>
-                <a:spcPts val="600"/>
-              </a:spcAft>
-              <a:defRPr/>
-            </a:pPr>
             <a:r>
               <a:rPr lang="en-US" dirty="0"/>
               <a:t>The attention layer and head that performs noun modifier:</a:t>
@@ -3659,7 +3919,7 @@
                 </a:solidFill>
                 <a:latin typeface="Consolas" panose="020B0609020204030204" pitchFamily="49" charset="0"/>
               </a:rPr>
-              <a:t>X</a:t>
+              <a:t>7</a:t>
             </a:r>
             <a:r>
               <a:rPr lang="en-US" dirty="0">
@@ -3677,7 +3937,7 @@
                 </a:solidFill>
                 <a:latin typeface="Consolas" panose="020B0609020204030204" pitchFamily="49" charset="0"/>
               </a:rPr>
-              <a:t>A</a:t>
+              <a:t>10</a:t>
             </a:r>
           </a:p>
           <a:p>
@@ -3927,6 +4187,66 @@
           </a:fontRef>
         </p:style>
       </p:cxnSp>
+      <p:pic>
+        <p:nvPicPr>
+          <p:cNvPr id="4" name="Picture 3">
+            <a:extLst>
+              <a:ext uri="{FF2B5EF4-FFF2-40B4-BE49-F238E27FC236}">
+                <a16:creationId xmlns:a16="http://schemas.microsoft.com/office/drawing/2014/main" id="{725B3051-F604-9F6F-A513-BE66293A8D3F}"/>
+              </a:ext>
+            </a:extLst>
+          </p:cNvPr>
+          <p:cNvPicPr>
+            <a:picLocks noChangeAspect="1"/>
+          </p:cNvPicPr>
+          <p:nvPr/>
+        </p:nvPicPr>
+        <p:blipFill>
+          <a:blip r:embed="rId2"/>
+          <a:stretch>
+            <a:fillRect/>
+          </a:stretch>
+        </p:blipFill>
+        <p:spPr>
+          <a:xfrm>
+            <a:off x="3511549" y="2662516"/>
+            <a:ext cx="3070465" cy="3907865"/>
+          </a:xfrm>
+          <a:prstGeom prst="rect">
+            <a:avLst/>
+          </a:prstGeom>
+        </p:spPr>
+      </p:pic>
+      <p:pic>
+        <p:nvPicPr>
+          <p:cNvPr id="7" name="Picture 6">
+            <a:extLst>
+              <a:ext uri="{FF2B5EF4-FFF2-40B4-BE49-F238E27FC236}">
+                <a16:creationId xmlns:a16="http://schemas.microsoft.com/office/drawing/2014/main" id="{3A1531F6-A605-DE50-6421-76897501AC82}"/>
+              </a:ext>
+            </a:extLst>
+          </p:cNvPr>
+          <p:cNvPicPr>
+            <a:picLocks noChangeAspect="1"/>
+          </p:cNvPicPr>
+          <p:nvPr/>
+        </p:nvPicPr>
+        <p:blipFill>
+          <a:blip r:embed="rId3"/>
+          <a:stretch>
+            <a:fillRect/>
+          </a:stretch>
+        </p:blipFill>
+        <p:spPr>
+          <a:xfrm>
+            <a:off x="8045593" y="2967436"/>
+            <a:ext cx="2656519" cy="3602945"/>
+          </a:xfrm>
+          <a:prstGeom prst="rect">
+            <a:avLst/>
+          </a:prstGeom>
+        </p:spPr>
+      </p:pic>
     </p:spTree>
     <p:extLst>
       <p:ext uri="{BB962C8B-B14F-4D97-AF65-F5344CB8AC3E}">
@@ -5683,17 +6003,8 @@
               <a:rPr lang="en-US" dirty="0">
                 <a:latin typeface="Consolas" panose="020B0609020204030204" pitchFamily="49" charset="0"/>
               </a:rPr>
-              <a:t>Comment on Both Model’s The model came out with a very simple single word answer, whereas the RAG went into an in depth technical analysis of what is necessary. To be fair, this question was also difficult to answer and it’s subjective as to which answer is preferable, but the RAG’s answer is more </a:t>
-            </a:r>
-            <a:r>
-              <a:rPr lang="en-US">
-                <a:latin typeface="Consolas" panose="020B0609020204030204" pitchFamily="49" charset="0"/>
-              </a:rPr>
-              <a:t>technically complete. </a:t>
-            </a:r>
-            <a:endParaRPr lang="en-US" dirty="0">
-              <a:latin typeface="Consolas" panose="020B0609020204030204" pitchFamily="49" charset="0"/>
-            </a:endParaRPr>
+              <a:t>Comment on Both Model’s The model came out with a very simple single word answer, whereas the RAG went into an in depth technical analysis of what is necessary. To be fair, this question was also difficult to answer and it’s subjective as to which answer is preferable, but the RAG’s answer is more technically complete. </a:t>
+            </a:r>
           </a:p>
           <a:p>
             <a:pPr lvl="0">
@@ -5886,7 +6197,7 @@
         <p:spPr>
           <a:xfrm>
             <a:off x="623455" y="1413164"/>
-            <a:ext cx="11239994" cy="6237605"/>
+            <a:ext cx="11239994" cy="6360716"/>
           </a:xfrm>
           <a:prstGeom prst="rect">
             <a:avLst/>
@@ -5910,7 +6221,7 @@
                 <a:latin typeface="Segoe UI" panose="020B0502040204020203" pitchFamily="34" charset="0"/>
                 <a:cs typeface="Segoe UI" panose="020B0502040204020203" pitchFamily="34" charset="0"/>
               </a:rPr>
-              <a:t>My answer: </a:t>
+              <a:t>My answer:  by creating several training features from one sample of our dataset</a:t>
             </a:r>
             <a:endParaRPr lang="en-US" dirty="0">
               <a:solidFill>
@@ -6111,32 +6422,6 @@
               </a:rPr>
               <a:t>RAG Output Screenshot:</a:t>
             </a:r>
-            <a:endParaRPr lang="en-US" sz="1600" dirty="0">
-              <a:latin typeface="Segoe UI" panose="020B0502040204020203" pitchFamily="34" charset="0"/>
-              <a:cs typeface="Segoe UI" panose="020B0502040204020203" pitchFamily="34" charset="0"/>
-            </a:endParaRPr>
-          </a:p>
-          <a:p>
-            <a:pPr lvl="0">
-              <a:spcAft>
-                <a:spcPts val="600"/>
-              </a:spcAft>
-              <a:defRPr/>
-            </a:pPr>
-            <a:endParaRPr lang="en-US" dirty="0">
-              <a:latin typeface="Consolas" panose="020B0609020204030204" pitchFamily="49" charset="0"/>
-            </a:endParaRPr>
-          </a:p>
-          <a:p>
-            <a:pPr lvl="0">
-              <a:spcAft>
-                <a:spcPts val="600"/>
-              </a:spcAft>
-              <a:defRPr/>
-            </a:pPr>
-            <a:endParaRPr lang="en-US" dirty="0">
-              <a:latin typeface="Consolas" panose="020B0609020204030204" pitchFamily="49" charset="0"/>
-            </a:endParaRPr>
           </a:p>
           <a:p>
             <a:pPr lvl="0">
@@ -6149,7 +6434,7 @@
               <a:rPr lang="en-US" dirty="0">
                 <a:latin typeface="Consolas" panose="020B0609020204030204" pitchFamily="49" charset="0"/>
               </a:rPr>
-              <a:t>Comment on Both Model’s Answer:</a:t>
+              <a:t>Comment on Both Model’s Answer: Once again the RAG outperforms the model, although the model effectively extracts the best answer from the context given, the context of having the entire PDF wins here as the RAG is able to articulate the implementation, such as the sliding window concept of context. </a:t>
             </a:r>
           </a:p>
           <a:p>
@@ -6212,8 +6497,38 @@
         </p:blipFill>
         <p:spPr>
           <a:xfrm>
-            <a:off x="3844636" y="4328914"/>
+            <a:off x="4037610" y="3752893"/>
             <a:ext cx="5365750" cy="709521"/>
+          </a:xfrm>
+          <a:prstGeom prst="rect">
+            <a:avLst/>
+          </a:prstGeom>
+        </p:spPr>
+      </p:pic>
+      <p:pic>
+        <p:nvPicPr>
+          <p:cNvPr id="4" name="Picture 3">
+            <a:extLst>
+              <a:ext uri="{FF2B5EF4-FFF2-40B4-BE49-F238E27FC236}">
+                <a16:creationId xmlns:a16="http://schemas.microsoft.com/office/drawing/2014/main" id="{2BB4B642-817E-8DE0-D2A3-9866D0E3BB7D}"/>
+              </a:ext>
+            </a:extLst>
+          </p:cNvPr>
+          <p:cNvPicPr>
+            <a:picLocks noChangeAspect="1"/>
+          </p:cNvPicPr>
+          <p:nvPr/>
+        </p:nvPicPr>
+        <p:blipFill>
+          <a:blip r:embed="rId3"/>
+          <a:stretch>
+            <a:fillRect/>
+          </a:stretch>
+        </p:blipFill>
+        <p:spPr>
+          <a:xfrm>
+            <a:off x="3710544" y="4495498"/>
+            <a:ext cx="5065816" cy="1062971"/>
           </a:xfrm>
           <a:prstGeom prst="rect">
             <a:avLst/>
@@ -6313,7 +6628,7 @@
         <p:spPr>
           <a:xfrm>
             <a:off x="623455" y="1413164"/>
-            <a:ext cx="11239994" cy="5606663"/>
+            <a:ext cx="11239994" cy="5129609"/>
           </a:xfrm>
           <a:prstGeom prst="rect">
             <a:avLst/>
@@ -6617,43 +6932,30 @@
               <a:rPr lang="en-US" dirty="0">
                 <a:latin typeface="Consolas" panose="020B0609020204030204" pitchFamily="49" charset="0"/>
               </a:rPr>
-              <a:t>Comment on Both Model’s Answer:</a:t>
-            </a:r>
-          </a:p>
-          <a:p>
-            <a:pPr lvl="0">
-              <a:spcAft>
-                <a:spcPts val="600"/>
-              </a:spcAft>
-              <a:defRPr/>
-            </a:pPr>
-            <a:endParaRPr lang="en-US" sz="1600" dirty="0">
-              <a:latin typeface="Segoe UI" panose="020B0502040204020203" pitchFamily="34" charset="0"/>
-              <a:cs typeface="Segoe UI" panose="020B0502040204020203" pitchFamily="34" charset="0"/>
-            </a:endParaRPr>
-          </a:p>
-          <a:p>
-            <a:pPr lvl="0">
-              <a:spcAft>
-                <a:spcPts val="600"/>
-              </a:spcAft>
-              <a:defRPr/>
-            </a:pPr>
-            <a:endParaRPr lang="en-US" sz="1600" dirty="0">
-              <a:latin typeface="Segoe UI" panose="020B0502040204020203" pitchFamily="34" charset="0"/>
-              <a:cs typeface="Segoe UI" panose="020B0502040204020203" pitchFamily="34" charset="0"/>
-            </a:endParaRPr>
-          </a:p>
-          <a:p>
-            <a:pPr lvl="0">
-              <a:spcAft>
-                <a:spcPts val="600"/>
-              </a:spcAft>
-              <a:defRPr/>
-            </a:pPr>
-            <a:endParaRPr lang="en-US" sz="1600" dirty="0">
-              <a:latin typeface="Segoe UI" panose="020B0502040204020203" pitchFamily="34" charset="0"/>
-              <a:cs typeface="Segoe UI" panose="020B0502040204020203" pitchFamily="34" charset="0"/>
+              <a:t>Comment on Both Model’s </a:t>
+            </a:r>
+            <a:r>
+              <a:rPr lang="en-US" dirty="0" err="1">
+                <a:latin typeface="Consolas" panose="020B0609020204030204" pitchFamily="49" charset="0"/>
+              </a:rPr>
+              <a:t>Answer:</a:t>
+            </a:r>
+            <a:r>
+              <a:rPr lang="en-US" sz="1600" dirty="0" err="1">
+                <a:latin typeface="Segoe UI" panose="020B0502040204020203" pitchFamily="34" charset="0"/>
+                <a:cs typeface="Segoe UI" panose="020B0502040204020203" pitchFamily="34" charset="0"/>
+              </a:rPr>
+              <a:t>The</a:t>
+            </a:r>
+            <a:r>
+              <a:rPr lang="en-US" sz="1600" dirty="0">
+                <a:latin typeface="Segoe UI" panose="020B0502040204020203" pitchFamily="34" charset="0"/>
+                <a:cs typeface="Segoe UI" panose="020B0502040204020203" pitchFamily="34" charset="0"/>
+              </a:rPr>
+              <a:t> previously mentioned patterns hold here. With the increased context afforded by processing the entire PDF, the RAG is able to draw on more data than the model, creating a better response. However, the model still does a decent job of extracting the best answer from the information given.  </a:t>
+            </a:r>
+            <a:endParaRPr lang="en-US" dirty="0">
+              <a:latin typeface="Consolas" panose="020B0609020204030204" pitchFamily="49" charset="0"/>
             </a:endParaRPr>
           </a:p>
         </p:txBody>
@@ -6682,6 +6984,36 @@
           <a:xfrm>
             <a:off x="3896015" y="3616035"/>
             <a:ext cx="5783447" cy="876877"/>
+          </a:xfrm>
+          <a:prstGeom prst="rect">
+            <a:avLst/>
+          </a:prstGeom>
+        </p:spPr>
+      </p:pic>
+      <p:pic>
+        <p:nvPicPr>
+          <p:cNvPr id="4" name="Picture 3">
+            <a:extLst>
+              <a:ext uri="{FF2B5EF4-FFF2-40B4-BE49-F238E27FC236}">
+                <a16:creationId xmlns:a16="http://schemas.microsoft.com/office/drawing/2014/main" id="{1051DC2C-C6EC-A54E-70BE-3C52F511DFE2}"/>
+              </a:ext>
+            </a:extLst>
+          </p:cNvPr>
+          <p:cNvPicPr>
+            <a:picLocks noChangeAspect="1"/>
+          </p:cNvPicPr>
+          <p:nvPr/>
+        </p:nvPicPr>
+        <p:blipFill>
+          <a:blip r:embed="rId3"/>
+          <a:stretch>
+            <a:fillRect/>
+          </a:stretch>
+        </p:blipFill>
+        <p:spPr>
+          <a:xfrm>
+            <a:off x="4655127" y="4492912"/>
+            <a:ext cx="4025735" cy="1303295"/>
           </a:xfrm>
           <a:prstGeom prst="rect">
             <a:avLst/>
@@ -6781,7 +7113,7 @@
         <p:spPr>
           <a:xfrm>
             <a:off x="623455" y="1413164"/>
-            <a:ext cx="11239994" cy="6940361"/>
+            <a:ext cx="11239994" cy="6124754"/>
           </a:xfrm>
           <a:prstGeom prst="rect">
             <a:avLst/>
@@ -6830,229 +7162,218 @@
               <a:defRPr/>
             </a:pPr>
             <a:r>
+              <a:rPr lang="en-US" sz="1000" dirty="0">
+                <a:latin typeface="Consolas" panose="020B0609020204030204" pitchFamily="49" charset="0"/>
+              </a:rPr>
+              <a:t>Context: </a:t>
+            </a:r>
+            <a:r>
+              <a:rPr lang="en-US" sz="1000" b="0" dirty="0">
+                <a:solidFill>
+                  <a:srgbClr val="CE9178"/>
+                </a:solidFill>
+                <a:effectLst/>
+                <a:latin typeface="Menlo" panose="020B0609030804020204" pitchFamily="49" charset="0"/>
+              </a:rPr>
+              <a:t>As we can see, our example has been in split into four inputs, each of them containing the </a:t>
+            </a:r>
+            <a:r>
+              <a:rPr lang="en-US" sz="1000" b="0" dirty="0" err="1">
+                <a:solidFill>
+                  <a:srgbClr val="CE9178"/>
+                </a:solidFill>
+                <a:effectLst/>
+                <a:latin typeface="Menlo" panose="020B0609030804020204" pitchFamily="49" charset="0"/>
+              </a:rPr>
+              <a:t>questionand</a:t>
+            </a:r>
+            <a:r>
+              <a:rPr lang="en-US" sz="1000" b="0" dirty="0">
+                <a:solidFill>
+                  <a:srgbClr val="CE9178"/>
+                </a:solidFill>
+                <a:effectLst/>
+                <a:latin typeface="Menlo" panose="020B0609030804020204" pitchFamily="49" charset="0"/>
+              </a:rPr>
+              <a:t> some part of the context. Note that the answer to the question (“Bernadette Soubirous”) </a:t>
+            </a:r>
+            <a:r>
+              <a:rPr lang="en-US" sz="1000" b="0" dirty="0" err="1">
+                <a:solidFill>
+                  <a:srgbClr val="CE9178"/>
+                </a:solidFill>
+                <a:effectLst/>
+                <a:latin typeface="Menlo" panose="020B0609030804020204" pitchFamily="49" charset="0"/>
+              </a:rPr>
+              <a:t>onlyappears</a:t>
+            </a:r>
+            <a:r>
+              <a:rPr lang="en-US" sz="1000" b="0" dirty="0">
+                <a:solidFill>
+                  <a:srgbClr val="CE9178"/>
+                </a:solidFill>
+                <a:effectLst/>
+                <a:latin typeface="Menlo" panose="020B0609030804020204" pitchFamily="49" charset="0"/>
+              </a:rPr>
+              <a:t> in the third and last inputs, so by dealing with long contexts in this way we will create </a:t>
+            </a:r>
+            <a:r>
+              <a:rPr lang="en-US" sz="1000" b="0" dirty="0" err="1">
+                <a:solidFill>
+                  <a:srgbClr val="CE9178"/>
+                </a:solidFill>
+                <a:effectLst/>
+                <a:latin typeface="Menlo" panose="020B0609030804020204" pitchFamily="49" charset="0"/>
+              </a:rPr>
+              <a:t>sometraining</a:t>
+            </a:r>
+            <a:r>
+              <a:rPr lang="en-US" sz="1000" b="0" dirty="0">
+                <a:solidFill>
+                  <a:srgbClr val="CE9178"/>
+                </a:solidFill>
+                <a:effectLst/>
+                <a:latin typeface="Menlo" panose="020B0609030804020204" pitchFamily="49" charset="0"/>
+              </a:rPr>
+              <a:t> examples where the answer is not included in the context. For those examples, the </a:t>
+            </a:r>
+            <a:r>
+              <a:rPr lang="en-US" sz="1000" b="0" dirty="0" err="1">
+                <a:solidFill>
+                  <a:srgbClr val="CE9178"/>
+                </a:solidFill>
+                <a:effectLst/>
+                <a:latin typeface="Menlo" panose="020B0609030804020204" pitchFamily="49" charset="0"/>
+              </a:rPr>
+              <a:t>labelswill</a:t>
+            </a:r>
+            <a:r>
+              <a:rPr lang="en-US" sz="1000" b="0" dirty="0">
+                <a:solidFill>
+                  <a:srgbClr val="CE9178"/>
+                </a:solidFill>
+                <a:effectLst/>
+                <a:latin typeface="Menlo" panose="020B0609030804020204" pitchFamily="49" charset="0"/>
+              </a:rPr>
+              <a:t> be </a:t>
+            </a:r>
+            <a:r>
+              <a:rPr lang="en-US" sz="1000" b="0" dirty="0" err="1">
+                <a:solidFill>
+                  <a:srgbClr val="CE9178"/>
+                </a:solidFill>
+                <a:effectLst/>
+                <a:latin typeface="Menlo" panose="020B0609030804020204" pitchFamily="49" charset="0"/>
+              </a:rPr>
+              <a:t>start_position</a:t>
+            </a:r>
+            <a:r>
+              <a:rPr lang="en-US" sz="1000" b="0" dirty="0">
+                <a:solidFill>
+                  <a:srgbClr val="CE9178"/>
+                </a:solidFill>
+                <a:effectLst/>
+                <a:latin typeface="Menlo" panose="020B0609030804020204" pitchFamily="49" charset="0"/>
+              </a:rPr>
+              <a:t> = </a:t>
+            </a:r>
+            <a:r>
+              <a:rPr lang="en-US" sz="1000" b="0" dirty="0" err="1">
+                <a:solidFill>
+                  <a:srgbClr val="CE9178"/>
+                </a:solidFill>
+                <a:effectLst/>
+                <a:latin typeface="Menlo" panose="020B0609030804020204" pitchFamily="49" charset="0"/>
+              </a:rPr>
+              <a:t>end_position</a:t>
+            </a:r>
+            <a:r>
+              <a:rPr lang="en-US" sz="1000" b="0" dirty="0">
+                <a:solidFill>
+                  <a:srgbClr val="CE9178"/>
+                </a:solidFill>
+                <a:effectLst/>
+                <a:latin typeface="Menlo" panose="020B0609030804020204" pitchFamily="49" charset="0"/>
+              </a:rPr>
+              <a:t> = 0 (so we predict the [CLS] token). We will also </a:t>
+            </a:r>
+            <a:r>
+              <a:rPr lang="en-US" sz="1000" b="0" dirty="0" err="1">
+                <a:solidFill>
+                  <a:srgbClr val="CE9178"/>
+                </a:solidFill>
+                <a:effectLst/>
+                <a:latin typeface="Menlo" panose="020B0609030804020204" pitchFamily="49" charset="0"/>
+              </a:rPr>
+              <a:t>setthose</a:t>
+            </a:r>
+            <a:r>
+              <a:rPr lang="en-US" sz="1000" b="0" dirty="0">
+                <a:solidFill>
+                  <a:srgbClr val="CE9178"/>
+                </a:solidFill>
+                <a:effectLst/>
+                <a:latin typeface="Menlo" panose="020B0609030804020204" pitchFamily="49" charset="0"/>
+              </a:rPr>
+              <a:t> labels in the unfortunate case where the answer has been truncated so that we only have </a:t>
+            </a:r>
+            <a:r>
+              <a:rPr lang="en-US" sz="1000" b="0" dirty="0" err="1">
+                <a:solidFill>
+                  <a:srgbClr val="CE9178"/>
+                </a:solidFill>
+                <a:effectLst/>
+                <a:latin typeface="Menlo" panose="020B0609030804020204" pitchFamily="49" charset="0"/>
+              </a:rPr>
+              <a:t>thestart</a:t>
+            </a:r>
+            <a:r>
+              <a:rPr lang="en-US" sz="1000" b="0" dirty="0">
+                <a:solidFill>
+                  <a:srgbClr val="CE9178"/>
+                </a:solidFill>
+                <a:effectLst/>
+                <a:latin typeface="Menlo" panose="020B0609030804020204" pitchFamily="49" charset="0"/>
+              </a:rPr>
+              <a:t> (or end) of it. For the examples where the answer is fully in the context, the labels will be </a:t>
+            </a:r>
+            <a:r>
+              <a:rPr lang="en-US" sz="1000" b="0" dirty="0" err="1">
+                <a:solidFill>
+                  <a:srgbClr val="CE9178"/>
+                </a:solidFill>
+                <a:effectLst/>
+                <a:latin typeface="Menlo" panose="020B0609030804020204" pitchFamily="49" charset="0"/>
+              </a:rPr>
+              <a:t>theindex</a:t>
+            </a:r>
+            <a:r>
+              <a:rPr lang="en-US" sz="1000" b="0" dirty="0">
+                <a:solidFill>
+                  <a:srgbClr val="CE9178"/>
+                </a:solidFill>
+                <a:effectLst/>
+                <a:latin typeface="Menlo" panose="020B0609030804020204" pitchFamily="49" charset="0"/>
+              </a:rPr>
+              <a:t> of the token where the answer starts and the index of the token where the answer ends.</a:t>
+            </a:r>
+            <a:endParaRPr lang="en-US" sz="1000" dirty="0">
+              <a:latin typeface="Consolas" panose="020B0609020204030204" pitchFamily="49" charset="0"/>
+            </a:endParaRPr>
+          </a:p>
+          <a:p>
+            <a:pPr lvl="0">
+              <a:spcAft>
+                <a:spcPts val="600"/>
+              </a:spcAft>
+              <a:defRPr/>
+            </a:pPr>
+            <a:r>
               <a:rPr lang="en-US" dirty="0">
                 <a:latin typeface="Consolas" panose="020B0609020204030204" pitchFamily="49" charset="0"/>
               </a:rPr>
-              <a:t>Context: </a:t>
-            </a:r>
-            <a:r>
-              <a:rPr lang="en-US" b="0" dirty="0">
-                <a:solidFill>
-                  <a:srgbClr val="CE9178"/>
-                </a:solidFill>
-                <a:effectLst/>
-                <a:latin typeface="Menlo" panose="020B0609030804020204" pitchFamily="49" charset="0"/>
-              </a:rPr>
-              <a:t>As we can see, our example has been in split into four inputs, each of them containing the </a:t>
-            </a:r>
-            <a:r>
-              <a:rPr lang="en-US" b="0" dirty="0" err="1">
-                <a:solidFill>
-                  <a:srgbClr val="CE9178"/>
-                </a:solidFill>
-                <a:effectLst/>
-                <a:latin typeface="Menlo" panose="020B0609030804020204" pitchFamily="49" charset="0"/>
-              </a:rPr>
-              <a:t>questionand</a:t>
-            </a:r>
-            <a:r>
-              <a:rPr lang="en-US" b="0" dirty="0">
-                <a:solidFill>
-                  <a:srgbClr val="CE9178"/>
-                </a:solidFill>
-                <a:effectLst/>
-                <a:latin typeface="Menlo" panose="020B0609030804020204" pitchFamily="49" charset="0"/>
-              </a:rPr>
-              <a:t> some part of the context. Note that the answer to the question (“Bernadette Soubirous”) </a:t>
-            </a:r>
-            <a:r>
-              <a:rPr lang="en-US" b="0" dirty="0" err="1">
-                <a:solidFill>
-                  <a:srgbClr val="CE9178"/>
-                </a:solidFill>
-                <a:effectLst/>
-                <a:latin typeface="Menlo" panose="020B0609030804020204" pitchFamily="49" charset="0"/>
-              </a:rPr>
-              <a:t>onlyappears</a:t>
-            </a:r>
-            <a:r>
-              <a:rPr lang="en-US" b="0" dirty="0">
-                <a:solidFill>
-                  <a:srgbClr val="CE9178"/>
-                </a:solidFill>
-                <a:effectLst/>
-                <a:latin typeface="Menlo" panose="020B0609030804020204" pitchFamily="49" charset="0"/>
-              </a:rPr>
-              <a:t> in the third and last inputs, so by dealing with long contexts in this way we will create </a:t>
-            </a:r>
-            <a:r>
-              <a:rPr lang="en-US" b="0" dirty="0" err="1">
-                <a:solidFill>
-                  <a:srgbClr val="CE9178"/>
-                </a:solidFill>
-                <a:effectLst/>
-                <a:latin typeface="Menlo" panose="020B0609030804020204" pitchFamily="49" charset="0"/>
-              </a:rPr>
-              <a:t>sometraining</a:t>
-            </a:r>
-            <a:r>
-              <a:rPr lang="en-US" b="0" dirty="0">
-                <a:solidFill>
-                  <a:srgbClr val="CE9178"/>
-                </a:solidFill>
-                <a:effectLst/>
-                <a:latin typeface="Menlo" panose="020B0609030804020204" pitchFamily="49" charset="0"/>
-              </a:rPr>
-              <a:t> examples where the answer is not included in the context. For those examples, the </a:t>
-            </a:r>
-            <a:r>
-              <a:rPr lang="en-US" b="0" dirty="0" err="1">
-                <a:solidFill>
-                  <a:srgbClr val="CE9178"/>
-                </a:solidFill>
-                <a:effectLst/>
-                <a:latin typeface="Menlo" panose="020B0609030804020204" pitchFamily="49" charset="0"/>
-              </a:rPr>
-              <a:t>labelswill</a:t>
-            </a:r>
-            <a:r>
-              <a:rPr lang="en-US" b="0" dirty="0">
-                <a:solidFill>
-                  <a:srgbClr val="CE9178"/>
-                </a:solidFill>
-                <a:effectLst/>
-                <a:latin typeface="Menlo" panose="020B0609030804020204" pitchFamily="49" charset="0"/>
-              </a:rPr>
-              <a:t> be </a:t>
-            </a:r>
-            <a:r>
-              <a:rPr lang="en-US" b="0" dirty="0" err="1">
-                <a:solidFill>
-                  <a:srgbClr val="CE9178"/>
-                </a:solidFill>
-                <a:effectLst/>
-                <a:latin typeface="Menlo" panose="020B0609030804020204" pitchFamily="49" charset="0"/>
-              </a:rPr>
-              <a:t>start_position</a:t>
-            </a:r>
-            <a:r>
-              <a:rPr lang="en-US" b="0" dirty="0">
-                <a:solidFill>
-                  <a:srgbClr val="CE9178"/>
-                </a:solidFill>
-                <a:effectLst/>
-                <a:latin typeface="Menlo" panose="020B0609030804020204" pitchFamily="49" charset="0"/>
-              </a:rPr>
-              <a:t> = </a:t>
-            </a:r>
-            <a:r>
-              <a:rPr lang="en-US" b="0" dirty="0" err="1">
-                <a:solidFill>
-                  <a:srgbClr val="CE9178"/>
-                </a:solidFill>
-                <a:effectLst/>
-                <a:latin typeface="Menlo" panose="020B0609030804020204" pitchFamily="49" charset="0"/>
-              </a:rPr>
-              <a:t>end_position</a:t>
-            </a:r>
-            <a:r>
-              <a:rPr lang="en-US" b="0" dirty="0">
-                <a:solidFill>
-                  <a:srgbClr val="CE9178"/>
-                </a:solidFill>
-                <a:effectLst/>
-                <a:latin typeface="Menlo" panose="020B0609030804020204" pitchFamily="49" charset="0"/>
-              </a:rPr>
-              <a:t> = 0 (so we predict the [CLS] token). We will also </a:t>
-            </a:r>
-            <a:r>
-              <a:rPr lang="en-US" b="0" dirty="0" err="1">
-                <a:solidFill>
-                  <a:srgbClr val="CE9178"/>
-                </a:solidFill>
-                <a:effectLst/>
-                <a:latin typeface="Menlo" panose="020B0609030804020204" pitchFamily="49" charset="0"/>
-              </a:rPr>
-              <a:t>setthose</a:t>
-            </a:r>
-            <a:r>
-              <a:rPr lang="en-US" b="0" dirty="0">
-                <a:solidFill>
-                  <a:srgbClr val="CE9178"/>
-                </a:solidFill>
-                <a:effectLst/>
-                <a:latin typeface="Menlo" panose="020B0609030804020204" pitchFamily="49" charset="0"/>
-              </a:rPr>
-              <a:t> labels in the unfortunate case where the answer has been truncated so that we only have </a:t>
-            </a:r>
-            <a:r>
-              <a:rPr lang="en-US" b="0" dirty="0" err="1">
-                <a:solidFill>
-                  <a:srgbClr val="CE9178"/>
-                </a:solidFill>
-                <a:effectLst/>
-                <a:latin typeface="Menlo" panose="020B0609030804020204" pitchFamily="49" charset="0"/>
-              </a:rPr>
-              <a:t>thestart</a:t>
-            </a:r>
-            <a:r>
-              <a:rPr lang="en-US" b="0" dirty="0">
-                <a:solidFill>
-                  <a:srgbClr val="CE9178"/>
-                </a:solidFill>
-                <a:effectLst/>
-                <a:latin typeface="Menlo" panose="020B0609030804020204" pitchFamily="49" charset="0"/>
-              </a:rPr>
-              <a:t> (or end) of it. For the examples where the answer is fully in the context, the labels will be </a:t>
-            </a:r>
-            <a:r>
-              <a:rPr lang="en-US" b="0" dirty="0" err="1">
-                <a:solidFill>
-                  <a:srgbClr val="CE9178"/>
-                </a:solidFill>
-                <a:effectLst/>
-                <a:latin typeface="Menlo" panose="020B0609030804020204" pitchFamily="49" charset="0"/>
-              </a:rPr>
-              <a:t>theindex</a:t>
-            </a:r>
-            <a:r>
-              <a:rPr lang="en-US" b="0" dirty="0">
-                <a:solidFill>
-                  <a:srgbClr val="CE9178"/>
-                </a:solidFill>
-                <a:effectLst/>
-                <a:latin typeface="Menlo" panose="020B0609030804020204" pitchFamily="49" charset="0"/>
-              </a:rPr>
-              <a:t> of the token where the answer starts and the index of the token where the answer ends.</a:t>
-            </a:r>
-            <a:endParaRPr lang="en-US" dirty="0">
-              <a:latin typeface="Consolas" panose="020B0609020204030204" pitchFamily="49" charset="0"/>
-            </a:endParaRPr>
-          </a:p>
-          <a:p>
-            <a:pPr lvl="0">
-              <a:spcAft>
-                <a:spcPts val="600"/>
-              </a:spcAft>
-              <a:defRPr/>
-            </a:pPr>
-            <a:r>
-              <a:rPr lang="en-US" dirty="0">
-                <a:latin typeface="Consolas" panose="020B0609020204030204" pitchFamily="49" charset="0"/>
-              </a:rPr>
               <a:t>Model Output Screenshot:</a:t>
             </a:r>
-          </a:p>
-          <a:p>
-            <a:pPr lvl="0">
-              <a:spcAft>
-                <a:spcPts val="600"/>
-              </a:spcAft>
-              <a:defRPr/>
-            </a:pPr>
-            <a:endParaRPr lang="en-US" dirty="0">
-              <a:latin typeface="Consolas" panose="020B0609020204030204" pitchFamily="49" charset="0"/>
-            </a:endParaRPr>
           </a:p>
           <a:p>
             <a:pPr lvl="0">
@@ -7116,7 +7437,31 @@
               <a:rPr lang="en-US" dirty="0">
                 <a:latin typeface="Consolas" panose="020B0609020204030204" pitchFamily="49" charset="0"/>
               </a:rPr>
-              <a:t>Comment on Both Model’s Answer:</a:t>
+              <a:t>Comment on Both Model’s Answer: This question was difficult for both me and the ML models to understand. We see that the </a:t>
+            </a:r>
+            <a:r>
+              <a:rPr lang="en-US" dirty="0" err="1">
+                <a:latin typeface="Consolas" panose="020B0609020204030204" pitchFamily="49" charset="0"/>
+              </a:rPr>
+              <a:t>modle</a:t>
+            </a:r>
+            <a:r>
+              <a:rPr lang="en-US" dirty="0">
+                <a:latin typeface="Consolas" panose="020B0609020204030204" pitchFamily="49" charset="0"/>
+              </a:rPr>
+              <a:t> actually does a little better here, as with a vague question having too much contexts confuses the RAG model a little bit. It writes a lot of stuff that is either not very correct or not very relevant. The Model we trained could use a slightly longer answer to explain that the ‘</a:t>
+            </a:r>
+            <a:r>
+              <a:rPr lang="en-US" dirty="0" err="1">
+                <a:latin typeface="Consolas" panose="020B0609020204030204" pitchFamily="49" charset="0"/>
+              </a:rPr>
+              <a:t>theindex</a:t>
+            </a:r>
+            <a:r>
+              <a:rPr lang="en-US" dirty="0">
+                <a:latin typeface="Consolas" panose="020B0609020204030204" pitchFamily="49" charset="0"/>
+              </a:rPr>
+              <a:t>’ refers to the index of the token where the answer starts and the index of the token where the answer ends. </a:t>
             </a:r>
           </a:p>
           <a:p>
@@ -7179,8 +7524,38 @@
         </p:blipFill>
         <p:spPr>
           <a:xfrm>
-            <a:off x="623455" y="5209886"/>
+            <a:off x="623455" y="3096078"/>
             <a:ext cx="7404100" cy="469900"/>
+          </a:xfrm>
+          <a:prstGeom prst="rect">
+            <a:avLst/>
+          </a:prstGeom>
+        </p:spPr>
+      </p:pic>
+      <p:pic>
+        <p:nvPicPr>
+          <p:cNvPr id="4" name="Picture 3">
+            <a:extLst>
+              <a:ext uri="{FF2B5EF4-FFF2-40B4-BE49-F238E27FC236}">
+                <a16:creationId xmlns:a16="http://schemas.microsoft.com/office/drawing/2014/main" id="{0AC79CEE-08B7-164E-F991-349647440C32}"/>
+              </a:ext>
+            </a:extLst>
+          </p:cNvPr>
+          <p:cNvPicPr>
+            <a:picLocks noChangeAspect="1"/>
+          </p:cNvPicPr>
+          <p:nvPr/>
+        </p:nvPicPr>
+        <p:blipFill>
+          <a:blip r:embed="rId3"/>
+          <a:stretch>
+            <a:fillRect/>
+          </a:stretch>
+        </p:blipFill>
+        <p:spPr>
+          <a:xfrm>
+            <a:off x="3527961" y="3509460"/>
+            <a:ext cx="6554190" cy="950735"/>
           </a:xfrm>
           <a:prstGeom prst="rect">
             <a:avLst/>
@@ -7288,7 +7663,7 @@
         <p:spPr>
           <a:xfrm>
             <a:off x="623455" y="1413164"/>
-            <a:ext cx="11239994" cy="5832366"/>
+            <a:ext cx="11239994" cy="5786199"/>
           </a:xfrm>
           <a:prstGeom prst="rect">
             <a:avLst/>
@@ -7563,16 +7938,20 @@
               <a:rPr lang="en-US" dirty="0">
                 <a:latin typeface="Consolas" panose="020B0609020204030204" pitchFamily="49" charset="0"/>
               </a:rPr>
-              <a:t>Comment on Both Model’s Answer:</a:t>
-            </a:r>
-          </a:p>
-          <a:p>
-            <a:pPr lvl="0">
-              <a:spcAft>
-                <a:spcPts val="600"/>
-              </a:spcAft>
-              <a:defRPr/>
-            </a:pPr>
+              <a:t>Comment on Both Model’s Answer: This one is where both models had the same answer(</a:t>
+            </a:r>
+            <a:r>
+              <a:rPr lang="en-US" dirty="0" err="1">
+                <a:latin typeface="Consolas" panose="020B0609020204030204" pitchFamily="49" charset="0"/>
+              </a:rPr>
+              <a:t>ish</a:t>
+            </a:r>
+            <a:r>
+              <a:rPr lang="en-US" dirty="0">
+                <a:latin typeface="Consolas" panose="020B0609020204030204" pitchFamily="49" charset="0"/>
+              </a:rPr>
+              <a:t>) but interestingly the RAG start talking about how the tokenizer is </a:t>
+            </a:r>
             <a:endParaRPr lang="en-US" sz="1600" dirty="0">
               <a:latin typeface="Segoe UI" panose="020B0502040204020203" pitchFamily="34" charset="0"/>
               <a:cs typeface="Segoe UI" panose="020B0502040204020203" pitchFamily="34" charset="0"/>
@@ -7628,6 +8007,36 @@
           <a:xfrm>
             <a:off x="3853652" y="3823854"/>
             <a:ext cx="4836611" cy="938447"/>
+          </a:xfrm>
+          <a:prstGeom prst="rect">
+            <a:avLst/>
+          </a:prstGeom>
+        </p:spPr>
+      </p:pic>
+      <p:pic>
+        <p:nvPicPr>
+          <p:cNvPr id="4" name="Picture 3">
+            <a:extLst>
+              <a:ext uri="{FF2B5EF4-FFF2-40B4-BE49-F238E27FC236}">
+                <a16:creationId xmlns:a16="http://schemas.microsoft.com/office/drawing/2014/main" id="{27DD31FF-3F57-F247-3CE6-09A6F65F6717}"/>
+              </a:ext>
+            </a:extLst>
+          </p:cNvPr>
+          <p:cNvPicPr>
+            <a:picLocks noChangeAspect="1"/>
+          </p:cNvPicPr>
+          <p:nvPr/>
+        </p:nvPicPr>
+        <p:blipFill>
+          <a:blip r:embed="rId3"/>
+          <a:stretch>
+            <a:fillRect/>
+          </a:stretch>
+        </p:blipFill>
+        <p:spPr>
+          <a:xfrm>
+            <a:off x="2209800" y="5087329"/>
+            <a:ext cx="7772400" cy="732182"/>
           </a:xfrm>
           <a:prstGeom prst="rect">
             <a:avLst/>

</xml_diff>